<commit_message>
added slides for Day 2
</commit_message>
<xml_diff>
--- a/slides/Day1/ANGSD.pptx
+++ b/slides/Day1/ANGSD.pptx
@@ -47,7 +47,7 @@
         <p:spPr>
           <a:xfrm>
             <a:off x="504000" y="226080"/>
-            <a:ext cx="9070920" cy="945720"/>
+            <a:ext cx="9070560" cy="945360"/>
           </a:xfrm>
           <a:prstGeom prst="rect">
             <a:avLst/>
@@ -148,7 +148,7 @@
         <p:txBody>
           <a:bodyPr/>
           <a:p>
-            <a:fld id="{35200685-FEF8-4D79-813B-B4E4DDF07912}" type="slidenum">
+            <a:fld id="{4D9CC497-FED8-4E93-BA5C-18D74D7C7222}" type="slidenum">
               <a:t>&lt;#&gt;</a:t>
             </a:fld>
           </a:p>
@@ -210,7 +210,7 @@
         <p:spPr>
           <a:xfrm>
             <a:off x="504000" y="226080"/>
-            <a:ext cx="9070920" cy="945720"/>
+            <a:ext cx="9070560" cy="945360"/>
           </a:xfrm>
           <a:prstGeom prst="rect">
             <a:avLst/>
@@ -259,7 +259,7 @@
         <p:spPr>
           <a:xfrm>
             <a:off x="3447360" y="5165280"/>
-            <a:ext cx="3194280" cy="389880"/>
+            <a:ext cx="3193920" cy="389520"/>
           </a:xfrm>
           <a:prstGeom prst="rect">
             <a:avLst/>
@@ -331,7 +331,7 @@
         <p:spPr>
           <a:xfrm>
             <a:off x="7227360" y="5165280"/>
-            <a:ext cx="2347560" cy="389880"/>
+            <a:ext cx="2347200" cy="389520"/>
           </a:xfrm>
           <a:prstGeom prst="rect">
             <a:avLst/>
@@ -372,7 +372,7 @@
                 <a:tab algn="l" pos="0"/>
               </a:tabLst>
             </a:pPr>
-            <a:fld id="{81A01458-C8C6-4679-A513-458B178AA8A9}" type="slidenum">
+            <a:fld id="{CDCC28C1-AB8D-406B-8ED8-83660B988205}" type="slidenum">
               <a:rPr b="0" lang="en-US" sz="1400" spc="-1" strike="noStrike">
                 <a:solidFill>
                   <a:srgbClr val="000000"/>
@@ -403,7 +403,7 @@
         <p:spPr>
           <a:xfrm>
             <a:off x="504000" y="5165280"/>
-            <a:ext cx="2347560" cy="389880"/>
+            <a:ext cx="2347200" cy="389520"/>
           </a:xfrm>
           <a:prstGeom prst="rect">
             <a:avLst/>
@@ -714,7 +714,7 @@
         <p:spPr>
           <a:xfrm>
             <a:off x="18360" y="9360"/>
-            <a:ext cx="10073520" cy="5668920"/>
+            <a:ext cx="10073160" cy="5668560"/>
           </a:xfrm>
           <a:prstGeom prst="rect">
             <a:avLst/>
@@ -733,7 +733,7 @@
         <p:spPr>
           <a:xfrm>
             <a:off x="1143000" y="613800"/>
-            <a:ext cx="6628680" cy="985680"/>
+            <a:ext cx="6628320" cy="985320"/>
           </a:xfrm>
           <a:prstGeom prst="rect">
             <a:avLst/>
@@ -758,6 +758,11 @@
             <a:noAutofit/>
           </a:bodyPr>
           <a:p>
+            <a:pPr>
+              <a:lnSpc>
+                <a:spcPct val="100000"/>
+              </a:lnSpc>
+            </a:pPr>
             <a:endParaRPr b="0" lang="en-US" sz="1800" spc="-1" strike="noStrike">
               <a:solidFill>
                 <a:srgbClr val="000000"/>
@@ -777,7 +782,7 @@
         <p:spPr>
           <a:xfrm>
             <a:off x="1180800" y="421200"/>
-            <a:ext cx="8822520" cy="884880"/>
+            <a:ext cx="8822160" cy="884520"/>
           </a:xfrm>
           <a:prstGeom prst="rect">
             <a:avLst/>
@@ -891,7 +896,7 @@
         <p:spPr>
           <a:xfrm>
             <a:off x="15480" y="9360"/>
-            <a:ext cx="10078920" cy="5668920"/>
+            <a:ext cx="10078560" cy="5668560"/>
           </a:xfrm>
           <a:prstGeom prst="rect">
             <a:avLst/>
@@ -944,7 +949,7 @@
         <p:spPr>
           <a:xfrm>
             <a:off x="15480" y="9360"/>
-            <a:ext cx="10078920" cy="5668920"/>
+            <a:ext cx="10078560" cy="5668560"/>
           </a:xfrm>
           <a:prstGeom prst="rect">
             <a:avLst/>
@@ -997,7 +1002,7 @@
         <p:spPr>
           <a:xfrm>
             <a:off x="15480" y="9360"/>
-            <a:ext cx="10078920" cy="5668920"/>
+            <a:ext cx="10078560" cy="5668560"/>
           </a:xfrm>
           <a:prstGeom prst="rect">
             <a:avLst/>
@@ -1050,7 +1055,7 @@
         <p:spPr>
           <a:xfrm>
             <a:off x="15480" y="9360"/>
-            <a:ext cx="10078920" cy="5668920"/>
+            <a:ext cx="10078560" cy="5668560"/>
           </a:xfrm>
           <a:prstGeom prst="rect">
             <a:avLst/>
@@ -1103,7 +1108,7 @@
         <p:spPr>
           <a:xfrm>
             <a:off x="15480" y="9360"/>
-            <a:ext cx="10078920" cy="5668920"/>
+            <a:ext cx="10078560" cy="5668560"/>
           </a:xfrm>
           <a:prstGeom prst="rect">
             <a:avLst/>

</xml_diff>